<commit_message>
Annotate slide 5 micrograph with per-process overlay markers
Bake UCP-styled overlay graphics into the PathologyOutlines micrograph
(motor cannot place shapes over slides): red ellipse on the globally
sclerosed glomerulus, red arrows + white/blue chips labeling interstitial
fibrosis and tubular atrophy. Histology pixels unchanged; 90 um scale bar
kept visible. Original photo kept as imgs/micro_rinon_web.jpg.

Co-authored-by: arena-agent <297053741+arena-agent@users.noreply.github.com>
</commit_message>
<xml_diff>
--- a/tema3-glomerulonefritis/tema3_glomerulonefritis_cronica.pptx
+++ b/tema3-glomerulonefritis/tema3_glomerulonefritis_cronica.pptx
@@ -7443,7 +7443,7 @@
       </p:sp>
       <p:pic>
         <p:nvPicPr>
-          <p:cNvPr id="9" name="Picture 8" descr="micro_rinon_web.jpg"/>
+          <p:cNvPr id="9" name="Picture 8" descr="micro_rinon_web_anotada.jpg"/>
           <p:cNvPicPr>
             <a:picLocks noChangeAspect="1"/>
           </p:cNvPicPr>
@@ -7502,7 +7502,7 @@
                 </a:solidFill>
                 <a:latin typeface="Montserrat"/>
               </a:rPr>
-              <a:t>Fibrosis intersticial con atrofia tubular y glomérulo con esclerosis global: histología del estadio terminal.</a:t>
+              <a:t>Micrografía anotada: esclerosis glomerular global, fibrosis intersticial y atrofia tubular.</a:t>
             </a:r>
           </a:p>
         </p:txBody>
@@ -7544,7 +7544,7 @@
                 </a:solidFill>
                 <a:latin typeface="Montserrat"/>
               </a:rPr>
-              <a:t>Tinciones H&amp;E, PAS y tricrómico de Masson · &gt; 85% de glomérulos con esclerosis global.  •  Crédito: PathologyOutlines — Interstitial fibrosis and tubular atrophy (pathologyoutlines.com)</a:t>
+              <a:t>Tinciones H&amp;E, PAS y tricrómico de Masson · &gt; 85% de glomérulos con esclerosis global.  •  Crédito: PathologyOutlines (pathologyoutlines.com) + anotación gráfica del Grupo 3</a:t>
             </a:r>
           </a:p>
         </p:txBody>

</xml_diff>